<commit_message>
Deck: research-backed roadmap on slide 5
Co-Authored-By: Claude Opus 5.5 <noreply@anthropic.com>
</commit_message>
<xml_diff>
--- a/docs/Envio-Claro-Deck.pptx
+++ b/docs/Envio-Claro-Deck.pptx
@@ -111,27 +111,27 @@
   <p:extLst>
     <p:ext uri="{521415D9-36F7-43E2-AB2F-B90AF26B5E84}">
       <p14:sectionLst xmlns:p14="http://schemas.microsoft.com/office/powerpoint/2010/main">
-        <p14:section name="Hook" id="{080d44bd-51db-2c7c-652d-ebc773de4b3b}">
+        <p14:section name="Hook" id="{94f5b78f-3d00-5eb7-8c97-904b9bc0ae67}">
           <p14:sldIdLst>
             <p14:sldId id="256"/>
           </p14:sldIdLst>
         </p14:section>
-        <p14:section name="Problem" id="{2dee75ac-d6a8-4331-3e2d-422f71851725}">
+        <p14:section name="Problem" id="{5d677c0d-ea57-9bb5-981e-234fdca9f73d}">
           <p14:sldIdLst>
             <p14:sldId id="257"/>
           </p14:sldIdLst>
         </p14:section>
-        <p14:section name="Product" id="{4035da12-7490-f327-0d8e-f636b21c3318}">
+        <p14:section name="Product" id="{73cd57b5-318b-a403-735e-df229e8c7de6}">
           <p14:sldIdLst>
             <p14:sldId id="258"/>
           </p14:sldIdLst>
         </p14:section>
-        <p14:section name="How it's built" id="{4b78795e-8dad-9487-aa5b-7f1f33f0c06e}">
+        <p14:section name="How it's built" id="{8e1c7da3-360f-81be-d7b6-77096f9f3ffd}">
           <p14:sldIdLst>
             <p14:sldId id="259"/>
           </p14:sldIdLst>
         </p14:section>
-        <p14:section name="Why now and next" id="{3d767947-fe16-5b6a-de55-494905c25268}">
+        <p14:section name="Why now and next" id="{48ff20d2-08f9-5665-d782-0d76765e0188}">
           <p14:sldIdLst>
             <p14:sldId id="260"/>
           </p14:sldIdLst>
@@ -4484,7 +4484,7 @@
                   <a:schemeClr val="tx1"/>
                 </a:solidFill>
               </a:rPr>
-              <a:t>WhatsApp Business approval (out of sandbox)</a:t>
+              <a:t>WhatsApp Business approval + opt-in alerts (rates, tax rules, scams)</a:t>
             </a:r>
             <a:endParaRPr lang="en-US" sz="1400" dirty="0"/>
           </a:p>
@@ -4502,7 +4502,7 @@
                   <a:schemeClr val="tx1"/>
                 </a:solidFill>
               </a:rPr>
-              <a:t>Live provider quotes + more countries (Perú, Nicaragua, Brasil)</a:t>
+              <a:t>Live provider quotes + “Rastrea tu envío” help</a:t>
             </a:r>
             <a:endParaRPr lang="en-US" sz="1400" dirty="0"/>
           </a:p>
@@ -4520,7 +4520,7 @@
                   <a:schemeClr val="tx1"/>
                 </a:solidFill>
               </a:rPr>
-              <a:t>Pilot with a NYC Financial Empowerment Center</a:t>
+              <a:t>Pilot with a NYC Financial Empowerment Center and no-SSN credit unions</a:t>
             </a:r>
             <a:endParaRPr lang="en-US" sz="1400" dirty="0"/>
           </a:p>

</xml_diff>

<commit_message>
Consistency audit: accurate README, privacy settings persisted (no call recording, 0-day agent retention), deck wording
Co-Authored-By: Claude Opus 5.5 <noreply@anthropic.com>
</commit_message>
<xml_diff>
--- a/docs/Envio-Claro-Deck.pptx
+++ b/docs/Envio-Claro-Deck.pptx
@@ -111,27 +111,27 @@
   <p:extLst>
     <p:ext uri="{521415D9-36F7-43E2-AB2F-B90AF26B5E84}">
       <p14:sectionLst xmlns:p14="http://schemas.microsoft.com/office/powerpoint/2010/main">
-        <p14:section name="Hook" id="{94f5b78f-3d00-5eb7-8c97-904b9bc0ae67}">
+        <p14:section name="Hook" id="{b2d4d8fb-5807-3327-ec59-422a57600177}">
           <p14:sldIdLst>
             <p14:sldId id="256"/>
           </p14:sldIdLst>
         </p14:section>
-        <p14:section name="Problem" id="{5d677c0d-ea57-9bb5-981e-234fdca9f73d}">
+        <p14:section name="Problem" id="{5d2c03d8-0628-63f3-a806-a9a277796869}">
           <p14:sldIdLst>
             <p14:sldId id="257"/>
           </p14:sldIdLst>
         </p14:section>
-        <p14:section name="Product" id="{73cd57b5-318b-a403-735e-df229e8c7de6}">
+        <p14:section name="Product" id="{f0a8f3f7-28e5-5106-b850-8d7db5e8f3a7}">
           <p14:sldIdLst>
             <p14:sldId id="258"/>
           </p14:sldIdLst>
         </p14:section>
-        <p14:section name="How it's built" id="{8e1c7da3-360f-81be-d7b6-77096f9f3ffd}">
+        <p14:section name="How it's built" id="{2a0a113c-c717-905d-5e1a-2e468f9bdd16}">
           <p14:sldIdLst>
             <p14:sldId id="259"/>
           </p14:sldIdLst>
         </p14:section>
-        <p14:section name="Why now and next" id="{48ff20d2-08f9-5665-d782-0d76765e0188}">
+        <p14:section name="Why now and next" id="{8fb5fab2-93f9-d1d4-291e-b2b889cccee0}">
           <p14:sldIdLst>
             <p14:sldId id="260"/>
           </p14:sldIdLst>
@@ -542,7 +542,7 @@
               <a:rPr lang="en-US" dirty="0"/>
               <a:t>[0:00–0:25] HOOK. Look at the room, not the slide.
 "On August 29th, Mexico's consumer protection agency compared what families get when they send 400 dollars home. The service with the LOWER fee, a dollar ninety-nine, delivered 6,628 pesos. The one charging 2.99 delivered 6,952. The cheaper fee cost that family 324 pesos, about 19 dollars. Every month.
-The fee is the part you see. The exchange rate is where the money goes, and nobody shows you that number before you pay. We built Envío Claro to show it, in Spanish, on the web, by phone, or by WhatsApp voice memo."</a:t>
+The fee is the part you see. The exchange rate is where the money goes, and providers don't have to show you that number before you pay. We built Envío Claro to show it, in Spanish, on the web, by phone, or by WhatsApp voice memo."</a:t>
             </a:r>
             <a:endParaRPr lang="en-US" dirty="0"/>
           </a:p>
@@ -1913,7 +1913,7 @@
                   <a:schemeClr val="bg2"/>
                 </a:solidFill>
               </a:rPr>
-              <a:t>The lower fee delivered less money. The difference was hidden in the exchange rate, and nobody shows senders that number before they pay. </a:t>
+              <a:t>The lower fee delivered less money. The difference was hidden in the exchange rate, and providers don't have to show senders that number before they pay. </a:t>
             </a:r>
             <a:pPr indent="0" marL="0">
               <a:buNone/>
@@ -4354,7 +4354,7 @@
                   <a:schemeClr val="tx1"/>
                 </a:solidFill>
               </a:rPr>
-              <a:t>Never paid by providers. Monito and others take referral fees; we don't</a:t>
+              <a:t>Never paid by providers (Monito, for example, earns referral fees; we don't)</a:t>
             </a:r>
             <a:endParaRPr lang="en-US" sz="1400" dirty="0"/>
           </a:p>

</xml_diff>

<commit_message>
Add Envío Claro logo (speech bubble + sending arrow) and use it in the deck
Co-Authored-By: Claude Opus 5.5 <noreply@anthropic.com>
</commit_message>
<xml_diff>
--- a/docs/Envio-Claro-Deck.pptx
+++ b/docs/Envio-Claro-Deck.pptx
@@ -111,27 +111,27 @@
   <p:extLst>
     <p:ext uri="{521415D9-36F7-43E2-AB2F-B90AF26B5E84}">
       <p14:sectionLst xmlns:p14="http://schemas.microsoft.com/office/powerpoint/2010/main">
-        <p14:section name="Hook" id="{b2d4d8fb-5807-3327-ec59-422a57600177}">
+        <p14:section name="Hook" id="{9d5eeb6c-abb0-5de0-e2de-56505a980f45}">
           <p14:sldIdLst>
             <p14:sldId id="256"/>
           </p14:sldIdLst>
         </p14:section>
-        <p14:section name="Problem" id="{5d2c03d8-0628-63f3-a806-a9a277796869}">
+        <p14:section name="Problem" id="{3527b891-edd2-d5e4-3ed7-610824016c47}">
           <p14:sldIdLst>
             <p14:sldId id="257"/>
           </p14:sldIdLst>
         </p14:section>
-        <p14:section name="Product" id="{f0a8f3f7-28e5-5106-b850-8d7db5e8f3a7}">
+        <p14:section name="Product" id="{8b6edd57-d394-6290-74c6-74b9d95e4af1}">
           <p14:sldIdLst>
             <p14:sldId id="258"/>
           </p14:sldIdLst>
         </p14:section>
-        <p14:section name="How it's built" id="{2a0a113c-c717-905d-5e1a-2e468f9bdd16}">
+        <p14:section name="How it's built" id="{fc18d9a3-7334-0ef7-da33-ba0e4a06b2d0}">
           <p14:sldIdLst>
             <p14:sldId id="259"/>
           </p14:sldIdLst>
         </p14:section>
-        <p14:section name="Why now and next" id="{8fb5fab2-93f9-d1d4-291e-b2b889cccee0}">
+        <p14:section name="Why now and next" id="{bc6bba54-7072-8089-d2bb-edf11b857ef9}">
           <p14:sldIdLst>
             <p14:sldId id="260"/>
           </p14:sldIdLst>
@@ -1015,7 +1015,7 @@
         </p:nvSpPr>
         <p:spPr>
           <a:xfrm>
-            <a:off x="685800" y="502920"/>
+            <a:off x="685800" y="1051560"/>
             <a:ext cx="10789920" cy="365760"/>
           </a:xfrm>
           <a:prstGeom prst="rect">
@@ -1054,8 +1054,8 @@
         </p:nvSpPr>
         <p:spPr>
           <a:xfrm>
-            <a:off x="685800" y="960120"/>
-            <a:ext cx="10789920" cy="1737360"/>
+            <a:off x="685800" y="1417320"/>
+            <a:ext cx="10789920" cy="1463040"/>
           </a:xfrm>
           <a:prstGeom prst="rect">
             <a:avLst/>
@@ -1068,7 +1068,7 @@
           <a:lstStyle>
             <a:lvl1pPr algn="l" indent="0" marL="0">
               <a:buNone/>
-              <a:defRPr lang="en-US" sz="5400" b="1" dirty="0">
+              <a:defRPr lang="en-US" sz="5000" b="1" dirty="0">
                 <a:solidFill>
                   <a:schemeClr val="bg1"/>
                 </a:solidFill>
@@ -1079,7 +1079,7 @@
             <a:pPr algn="l" indent="0" marL="0">
               <a:buNone/>
             </a:pPr>
-            <a:endParaRPr lang="en-US" sz="5400" dirty="0"/>
+            <a:endParaRPr lang="en-US" sz="5000" dirty="0"/>
           </a:p>
         </p:txBody>
       </p:sp>
@@ -1193,15 +1193,39 @@
           </a:p>
         </p:txBody>
       </p:sp>
-      <p:sp>
-        <p:nvSpPr>
-          <p:cNvPr id="4" name="Text 0"/>
+      <p:pic>
+        <p:nvPicPr>
+          <p:cNvPr id="4" name="Image 0" descr="/Users/carltonking/Hackathons/Latinos x AI/deck/logo/logo-mark.png">    </p:cNvPr>
+          <p:cNvPicPr>
+            <a:picLocks noChangeAspect="1"/>
+          </p:cNvPicPr>
+          <p:nvPr/>
+        </p:nvPicPr>
+        <p:blipFill>
+          <a:blip r:embed="rId1"/>
+          <a:stretch>
+            <a:fillRect/>
+          </a:stretch>
+        </p:blipFill>
+        <p:spPr>
+          <a:xfrm>
+            <a:off x="685800" y="6382512"/>
+            <a:ext cx="274320" cy="274320"/>
+          </a:xfrm>
+          <a:prstGeom prst="rect">
+            <a:avLst/>
+          </a:prstGeom>
+        </p:spPr>
+      </p:pic>
+      <p:sp>
+        <p:nvSpPr>
+          <p:cNvPr id="5" name="Text 0"/>
           <p:cNvSpPr/>
           <p:nvPr/>
         </p:nvSpPr>
         <p:spPr>
           <a:xfrm>
-            <a:off x="685800" y="6400800"/>
+            <a:off x="1024128" y="6400800"/>
             <a:ext cx="3657600" cy="274320"/>
           </a:xfrm>
           <a:prstGeom prst="rect">
@@ -1623,9 +1647,33 @@
           <a:chExt cx="0" cy="0"/>
         </a:xfrm>
       </p:grpSpPr>
-      <p:sp>
-        <p:nvSpPr>
-          <p:cNvPr id="2" name="Text 0"/>
+      <p:pic>
+        <p:nvPicPr>
+          <p:cNvPr id="2" name="logo" descr="Envío Claro logo">    </p:cNvPr>
+          <p:cNvPicPr>
+            <a:picLocks noChangeAspect="1"/>
+          </p:cNvPicPr>
+          <p:nvPr/>
+        </p:nvPicPr>
+        <p:blipFill>
+          <a:blip r:embed="rId1"/>
+          <a:stretch>
+            <a:fillRect/>
+          </a:stretch>
+        </p:blipFill>
+        <p:spPr>
+          <a:xfrm>
+            <a:off x="685800" y="457200"/>
+            <a:ext cx="1700784" cy="411480"/>
+          </a:xfrm>
+          <a:prstGeom prst="rect">
+            <a:avLst/>
+          </a:prstGeom>
+        </p:spPr>
+      </p:pic>
+      <p:sp>
+        <p:nvSpPr>
+          <p:cNvPr id="3" name="Text 0"/>
           <p:cNvSpPr/>
           <p:nvPr>
             <p:ph idx="100" type="body" hasCustomPrompt="1"/>
@@ -1633,7 +1681,7 @@
         </p:nvSpPr>
         <p:spPr>
           <a:xfrm>
-            <a:off x="685800" y="502920"/>
+            <a:off x="685800" y="1051560"/>
             <a:ext cx="10789920" cy="365760"/>
           </a:xfrm>
           <a:prstGeom prst="rect">
@@ -1663,7 +1711,7 @@
       </p:sp>
       <p:sp>
         <p:nvSpPr>
-          <p:cNvPr id="3" name="Text 0"/>
+          <p:cNvPr id="4" name="Text 0"/>
           <p:cNvSpPr/>
           <p:nvPr>
             <p:ph idx="101" type="title" hasCustomPrompt="1"/>
@@ -1671,8 +1719,8 @@
         </p:nvSpPr>
         <p:spPr>
           <a:xfrm>
-            <a:off x="685800" y="960120"/>
-            <a:ext cx="10789920" cy="1737360"/>
+            <a:off x="685800" y="1417320"/>
+            <a:ext cx="10789920" cy="1463040"/>
           </a:xfrm>
           <a:prstGeom prst="rect">
             <a:avLst/>
@@ -1688,7 +1736,7 @@
               <a:buNone/>
             </a:pPr>
             <a:r>
-              <a:rPr lang="en-US" sz="5400" b="1" dirty="0">
+              <a:rPr lang="en-US" sz="5000" b="1" dirty="0">
                 <a:solidFill>
                   <a:schemeClr val="bg1"/>
                 </a:solidFill>
@@ -1699,7 +1747,7 @@
               <a:buNone/>
             </a:pPr>
             <a:r>
-              <a:rPr lang="en-US" sz="5400" b="1" dirty="0">
+              <a:rPr lang="en-US" sz="5000" b="1" dirty="0">
                 <a:solidFill>
                   <a:schemeClr val="accent5"/>
                 </a:solidFill>
@@ -1710,20 +1758,20 @@
               <a:buNone/>
             </a:pPr>
             <a:r>
-              <a:rPr lang="en-US" sz="5400" b="1" dirty="0">
+              <a:rPr lang="en-US" sz="5000" b="1" dirty="0">
                 <a:solidFill>
                   <a:schemeClr val="bg1"/>
                 </a:solidFill>
               </a:rPr>
               <a:t>.”</a:t>
             </a:r>
-            <a:endParaRPr lang="en-US" sz="5400" dirty="0"/>
-          </a:p>
-        </p:txBody>
-      </p:sp>
-      <p:sp>
-        <p:nvSpPr>
-          <p:cNvPr id="4" name="compare-0"/>
+            <a:endParaRPr lang="en-US" sz="5000" dirty="0"/>
+          </a:p>
+        </p:txBody>
+      </p:sp>
+      <p:sp>
+        <p:nvSpPr>
+          <p:cNvPr id="5" name="compare-0"/>
           <p:cNvSpPr/>
           <p:nvPr/>
         </p:nvSpPr>
@@ -1754,7 +1802,7 @@
       </p:sp>
       <p:sp>
         <p:nvSpPr>
-          <p:cNvPr id="5" name="compare-text-0"/>
+          <p:cNvPr id="6" name="compare-text-0"/>
           <p:cNvSpPr txBox="1"/>
           <p:nvPr/>
         </p:nvSpPr>
@@ -1804,7 +1852,7 @@
       </p:sp>
       <p:sp>
         <p:nvSpPr>
-          <p:cNvPr id="6" name="compare-1"/>
+          <p:cNvPr id="7" name="compare-1"/>
           <p:cNvSpPr/>
           <p:nvPr/>
         </p:nvSpPr>
@@ -1835,7 +1883,7 @@
       </p:sp>
       <p:sp>
         <p:nvSpPr>
-          <p:cNvPr id="7" name="compare-text-1"/>
+          <p:cNvPr id="8" name="compare-text-1"/>
           <p:cNvSpPr txBox="1"/>
           <p:nvPr/>
         </p:nvSpPr>
@@ -1885,7 +1933,7 @@
       </p:sp>
       <p:sp>
         <p:nvSpPr>
-          <p:cNvPr id="8" name="hook-body"/>
+          <p:cNvPr id="9" name="hook-body"/>
           <p:cNvSpPr txBox="1"/>
           <p:nvPr/>
         </p:nvSpPr>
@@ -1932,7 +1980,7 @@
       </p:sp>
       <p:sp>
         <p:nvSpPr>
-          <p:cNvPr id="9" name="hook-source"/>
+          <p:cNvPr id="10" name="hook-source"/>
           <p:cNvSpPr txBox="1"/>
           <p:nvPr/>
         </p:nvSpPr>
@@ -1968,7 +2016,7 @@
       </p:sp>
       <p:sp>
         <p:nvSpPr>
-          <p:cNvPr id="10" name="hook-event"/>
+          <p:cNvPr id="11" name="hook-event"/>
           <p:cNvSpPr txBox="1"/>
           <p:nvPr/>
         </p:nvSpPr>

</xml_diff>

<commit_message>
Deck: cover spacing with logo
Co-Authored-By: Claude Opus 5.5 <noreply@anthropic.com>
</commit_message>
<xml_diff>
--- a/docs/Envio-Claro-Deck.pptx
+++ b/docs/Envio-Claro-Deck.pptx
@@ -111,27 +111,27 @@
   <p:extLst>
     <p:ext uri="{521415D9-36F7-43E2-AB2F-B90AF26B5E84}">
       <p14:sectionLst xmlns:p14="http://schemas.microsoft.com/office/powerpoint/2010/main">
-        <p14:section name="Hook" id="{9d5eeb6c-abb0-5de0-e2de-56505a980f45}">
+        <p14:section name="Hook" id="{162d4b84-56e0-6236-b984-05c7916b7612}">
           <p14:sldIdLst>
             <p14:sldId id="256"/>
           </p14:sldIdLst>
         </p14:section>
-        <p14:section name="Problem" id="{3527b891-edd2-d5e4-3ed7-610824016c47}">
+        <p14:section name="Problem" id="{198abf28-8f6b-636e-4566-8609ebfb3ec5}">
           <p14:sldIdLst>
             <p14:sldId id="257"/>
           </p14:sldIdLst>
         </p14:section>
-        <p14:section name="Product" id="{8b6edd57-d394-6290-74c6-74b9d95e4af1}">
+        <p14:section name="Product" id="{9bdd881b-7e03-be77-7246-42c544558f57}">
           <p14:sldIdLst>
             <p14:sldId id="258"/>
           </p14:sldIdLst>
         </p14:section>
-        <p14:section name="How it's built" id="{fc18d9a3-7334-0ef7-da33-ba0e4a06b2d0}">
+        <p14:section name="How it's built" id="{626ae987-18c3-0bd2-8aa1-f4d2ca25b620}">
           <p14:sldIdLst>
             <p14:sldId id="259"/>
           </p14:sldIdLst>
         </p14:section>
-        <p14:section name="Why now and next" id="{bc6bba54-7072-8089-d2bb-edf11b857ef9}">
+        <p14:section name="Why now and next" id="{e0222698-3833-9053-b999-4a1d763eb860}">
           <p14:sldIdLst>
             <p14:sldId id="260"/>
           </p14:sldIdLst>
@@ -1777,7 +1777,7 @@
         </p:nvSpPr>
         <p:spPr>
           <a:xfrm>
-            <a:off x="685800" y="2926080"/>
+            <a:off x="685800" y="3246120"/>
             <a:ext cx="4206240" cy="1051560"/>
           </a:xfrm>
           <a:prstGeom prst="roundRect">
@@ -1808,7 +1808,7 @@
         </p:nvSpPr>
         <p:spPr>
           <a:xfrm>
-            <a:off x="914400" y="3017520"/>
+            <a:off x="914400" y="3337560"/>
             <a:ext cx="3840480" cy="868680"/>
           </a:xfrm>
           <a:prstGeom prst="rect">
@@ -1858,7 +1858,7 @@
         </p:nvSpPr>
         <p:spPr>
           <a:xfrm>
-            <a:off x="5074920" y="2926080"/>
+            <a:off x="5074920" y="3246120"/>
             <a:ext cx="4206240" cy="1051560"/>
           </a:xfrm>
           <a:prstGeom prst="roundRect">
@@ -1889,7 +1889,7 @@
         </p:nvSpPr>
         <p:spPr>
           <a:xfrm>
-            <a:off x="5303520" y="3017520"/>
+            <a:off x="5303520" y="3337560"/>
             <a:ext cx="3840480" cy="868680"/>
           </a:xfrm>
           <a:prstGeom prst="rect">
@@ -1939,7 +1939,7 @@
         </p:nvSpPr>
         <p:spPr>
           <a:xfrm>
-            <a:off x="685800" y="4297680"/>
+            <a:off x="685800" y="4572000"/>
             <a:ext cx="10058400" cy="1188720"/>
           </a:xfrm>
           <a:prstGeom prst="rect">

</xml_diff>